<commit_message>
Subcategory- working with status update
</commit_message>
<xml_diff>
--- a/.lessons/56 Category, Subcategory and Child Category Setup/13 Subcategory- working with status update/1.pptx
+++ b/.lessons/56 Category, Subcategory and Child Category Setup/13 Subcategory- working with status update/1.pptx
@@ -6,8 +6,8 @@
   </p:sldMasterIdLst>
   <p:sldIdLst>
     <p:sldId id="413" r:id="rId2"/>
-    <p:sldId id="414" r:id="rId3"/>
-    <p:sldId id="400" r:id="rId4"/>
+    <p:sldId id="400" r:id="rId3"/>
+    <p:sldId id="414" r:id="rId4"/>
   </p:sldIdLst>
   <p:sldSz cx="12192000" cy="6858000"/>
   <p:notesSz cx="6858000" cy="9144000"/>
@@ -261,7 +261,7 @@
           <a:p>
             <a:fld id="{3E102D2E-813C-461C-9963-687A650C48C0}" type="datetimeFigureOut">
               <a:rPr lang="en-US" smtClean="0"/>
-              <a:t>6/26/2025</a:t>
+              <a:t>8/22/2025</a:t>
             </a:fld>
             <a:endParaRPr lang="en-US"/>
           </a:p>
@@ -459,7 +459,7 @@
           <a:p>
             <a:fld id="{3E102D2E-813C-461C-9963-687A650C48C0}" type="datetimeFigureOut">
               <a:rPr lang="en-US" smtClean="0"/>
-              <a:t>6/26/2025</a:t>
+              <a:t>8/22/2025</a:t>
             </a:fld>
             <a:endParaRPr lang="en-US"/>
           </a:p>
@@ -667,7 +667,7 @@
           <a:p>
             <a:fld id="{3E102D2E-813C-461C-9963-687A650C48C0}" type="datetimeFigureOut">
               <a:rPr lang="en-US" smtClean="0"/>
-              <a:t>6/26/2025</a:t>
+              <a:t>8/22/2025</a:t>
             </a:fld>
             <a:endParaRPr lang="en-US"/>
           </a:p>
@@ -865,7 +865,7 @@
           <a:p>
             <a:fld id="{3E102D2E-813C-461C-9963-687A650C48C0}" type="datetimeFigureOut">
               <a:rPr lang="en-US" smtClean="0"/>
-              <a:t>6/26/2025</a:t>
+              <a:t>8/22/2025</a:t>
             </a:fld>
             <a:endParaRPr lang="en-US"/>
           </a:p>
@@ -1140,7 +1140,7 @@
           <a:p>
             <a:fld id="{3E102D2E-813C-461C-9963-687A650C48C0}" type="datetimeFigureOut">
               <a:rPr lang="en-US" smtClean="0"/>
-              <a:t>6/26/2025</a:t>
+              <a:t>8/22/2025</a:t>
             </a:fld>
             <a:endParaRPr lang="en-US"/>
           </a:p>
@@ -1405,7 +1405,7 @@
           <a:p>
             <a:fld id="{3E102D2E-813C-461C-9963-687A650C48C0}" type="datetimeFigureOut">
               <a:rPr lang="en-US" smtClean="0"/>
-              <a:t>6/26/2025</a:t>
+              <a:t>8/22/2025</a:t>
             </a:fld>
             <a:endParaRPr lang="en-US"/>
           </a:p>
@@ -1817,7 +1817,7 @@
           <a:p>
             <a:fld id="{3E102D2E-813C-461C-9963-687A650C48C0}" type="datetimeFigureOut">
               <a:rPr lang="en-US" smtClean="0"/>
-              <a:t>6/26/2025</a:t>
+              <a:t>8/22/2025</a:t>
             </a:fld>
             <a:endParaRPr lang="en-US"/>
           </a:p>
@@ -1958,7 +1958,7 @@
           <a:p>
             <a:fld id="{3E102D2E-813C-461C-9963-687A650C48C0}" type="datetimeFigureOut">
               <a:rPr lang="en-US" smtClean="0"/>
-              <a:t>6/26/2025</a:t>
+              <a:t>8/22/2025</a:t>
             </a:fld>
             <a:endParaRPr lang="en-US"/>
           </a:p>
@@ -2071,7 +2071,7 @@
           <a:p>
             <a:fld id="{3E102D2E-813C-461C-9963-687A650C48C0}" type="datetimeFigureOut">
               <a:rPr lang="en-US" smtClean="0"/>
-              <a:t>6/26/2025</a:t>
+              <a:t>8/22/2025</a:t>
             </a:fld>
             <a:endParaRPr lang="en-US"/>
           </a:p>
@@ -2382,7 +2382,7 @@
           <a:p>
             <a:fld id="{3E102D2E-813C-461C-9963-687A650C48C0}" type="datetimeFigureOut">
               <a:rPr lang="en-US" smtClean="0"/>
-              <a:t>6/26/2025</a:t>
+              <a:t>8/22/2025</a:t>
             </a:fld>
             <a:endParaRPr lang="en-US"/>
           </a:p>
@@ -2670,7 +2670,7 @@
           <a:p>
             <a:fld id="{3E102D2E-813C-461C-9963-687A650C48C0}" type="datetimeFigureOut">
               <a:rPr lang="en-US" smtClean="0"/>
-              <a:t>6/26/2025</a:t>
+              <a:t>8/22/2025</a:t>
             </a:fld>
             <a:endParaRPr lang="en-US"/>
           </a:p>
@@ -2911,7 +2911,7 @@
           <a:p>
             <a:fld id="{3E102D2E-813C-461C-9963-687A650C48C0}" type="datetimeFigureOut">
               <a:rPr lang="en-US" smtClean="0"/>
-              <a:t>6/26/2025</a:t>
+              <a:t>8/22/2025</a:t>
             </a:fld>
             <a:endParaRPr lang="en-US"/>
           </a:p>
@@ -3349,7 +3349,7 @@
         <p:spPr>
           <a:xfrm>
             <a:off x="217714" y="255046"/>
-            <a:ext cx="11756571" cy="355354"/>
+            <a:ext cx="11756571" cy="655436"/>
           </a:xfrm>
           <a:prstGeom prst="rect">
             <a:avLst/>
@@ -3362,28 +3362,75 @@
           </a:bodyPr>
           <a:lstStyle/>
           <a:p>
-            <a:pPr>
+            <a:pPr marL="342900" indent="-342900">
               <a:lnSpc>
                 <a:spcPct val="150000"/>
               </a:lnSpc>
-              <a:buNone/>
+              <a:buAutoNum type="arabicParenR"/>
             </a:pPr>
             <a:r>
-              <a:rPr kumimoji="0" lang="en-US" altLang="en-US" sz="1300" b="0" i="0" u="none" strike="noStrike" cap="none" normalizeH="0" baseline="0">
-                <a:ln>
-                  <a:noFill/>
-                </a:ln>
-                <a:solidFill>
-                  <a:schemeClr val="tx1"/>
-                </a:solidFill>
-                <a:effectLst/>
+              <a:rPr lang="en-US" altLang="en-US" sz="1300">
                 <a:latin typeface="Arial" panose="020B0604020202020204" pitchFamily="34" charset="0"/>
               </a:rPr>
-              <a:t>.</a:t>
-            </a:r>
-          </a:p>
-        </p:txBody>
-      </p:sp>
+              <a:t>resources\views\admin\sub-category\index.blade.php</a:t>
+            </a:r>
+          </a:p>
+          <a:p>
+            <a:pPr marL="342900" indent="-342900">
+              <a:lnSpc>
+                <a:spcPct val="150000"/>
+              </a:lnSpc>
+              <a:buAutoNum type="arabicParenR"/>
+            </a:pPr>
+            <a:r>
+              <a:rPr lang="en-US" altLang="en-US" sz="1300">
+                <a:latin typeface="Arial" panose="020B0604020202020204" pitchFamily="34" charset="0"/>
+              </a:rPr>
+              <a:t>app\Http\Controllers\Backend\SubCategoryController.php</a:t>
+            </a:r>
+            <a:endParaRPr kumimoji="0" lang="en-US" altLang="en-US" sz="1300" b="0" i="0" u="none" strike="noStrike" cap="none" normalizeH="0" baseline="0">
+              <a:ln>
+                <a:noFill/>
+              </a:ln>
+              <a:solidFill>
+                <a:schemeClr val="tx1"/>
+              </a:solidFill>
+              <a:effectLst/>
+              <a:latin typeface="Arial" panose="020B0604020202020204" pitchFamily="34" charset="0"/>
+            </a:endParaRPr>
+          </a:p>
+        </p:txBody>
+      </p:sp>
+      <p:pic>
+        <p:nvPicPr>
+          <p:cNvPr id="4" name="Picture 3">
+            <a:extLst>
+              <a:ext uri="{FF2B5EF4-FFF2-40B4-BE49-F238E27FC236}">
+                <a16:creationId xmlns:a16="http://schemas.microsoft.com/office/drawing/2014/main" id="{90547D3E-8B7B-FE23-4DBE-C3DA80D28359}"/>
+              </a:ext>
+            </a:extLst>
+          </p:cNvPr>
+          <p:cNvPicPr>
+            <a:picLocks noChangeAspect="1"/>
+          </p:cNvPicPr>
+          <p:nvPr/>
+        </p:nvPicPr>
+        <p:blipFill>
+          <a:blip r:embed="rId2"/>
+          <a:stretch>
+            <a:fillRect/>
+          </a:stretch>
+        </p:blipFill>
+        <p:spPr>
+          <a:xfrm>
+            <a:off x="2770908" y="1460240"/>
+            <a:ext cx="9421091" cy="5397760"/>
+          </a:xfrm>
+          <a:prstGeom prst="rect">
+            <a:avLst/>
+          </a:prstGeom>
+        </p:spPr>
+      </p:pic>
     </p:spTree>
     <p:extLst>
       <p:ext uri="{BB962C8B-B14F-4D97-AF65-F5344CB8AC3E}">
@@ -3398,92 +3445,6 @@
 </file>
 
 <file path=ppt/slides/slide2.xml><?xml version="1.0" encoding="utf-8"?>
-<p:sld xmlns:a="http://schemas.openxmlformats.org/drawingml/2006/main" xmlns:r="http://schemas.openxmlformats.org/officeDocument/2006/relationships" xmlns:p="http://schemas.openxmlformats.org/presentationml/2006/main">
-  <p:cSld>
-    <p:spTree>
-      <p:nvGrpSpPr>
-        <p:cNvPr id="1" name="">
-          <a:extLst>
-            <a:ext uri="{FF2B5EF4-FFF2-40B4-BE49-F238E27FC236}">
-              <a16:creationId xmlns:a16="http://schemas.microsoft.com/office/drawing/2014/main" id="{E0B23C97-7391-808C-8F93-F1A247B54F0E}"/>
-            </a:ext>
-          </a:extLst>
-        </p:cNvPr>
-        <p:cNvGrpSpPr/>
-        <p:nvPr/>
-      </p:nvGrpSpPr>
-      <p:grpSpPr>
-        <a:xfrm>
-          <a:off x="0" y="0"/>
-          <a:ext cx="0" cy="0"/>
-          <a:chOff x="0" y="0"/>
-          <a:chExt cx="0" cy="0"/>
-        </a:xfrm>
-      </p:grpSpPr>
-      <p:sp>
-        <p:nvSpPr>
-          <p:cNvPr id="3" name="TextBox 2">
-            <a:extLst>
-              <a:ext uri="{FF2B5EF4-FFF2-40B4-BE49-F238E27FC236}">
-                <a16:creationId xmlns:a16="http://schemas.microsoft.com/office/drawing/2014/main" id="{D9BA728D-9AF8-6C25-DF35-1494919186BC}"/>
-              </a:ext>
-            </a:extLst>
-          </p:cNvPr>
-          <p:cNvSpPr txBox="1"/>
-          <p:nvPr/>
-        </p:nvSpPr>
-        <p:spPr>
-          <a:xfrm>
-            <a:off x="217714" y="255046"/>
-            <a:ext cx="11756571" cy="355354"/>
-          </a:xfrm>
-          <a:prstGeom prst="rect">
-            <a:avLst/>
-          </a:prstGeom>
-          <a:noFill/>
-        </p:spPr>
-        <p:txBody>
-          <a:bodyPr wrap="square">
-            <a:spAutoFit/>
-          </a:bodyPr>
-          <a:lstStyle/>
-          <a:p>
-            <a:pPr>
-              <a:lnSpc>
-                <a:spcPct val="150000"/>
-              </a:lnSpc>
-              <a:buNone/>
-            </a:pPr>
-            <a:r>
-              <a:rPr kumimoji="0" lang="en-US" altLang="en-US" sz="1300" b="0" i="0" u="none" strike="noStrike" cap="none" normalizeH="0" baseline="0">
-                <a:ln>
-                  <a:noFill/>
-                </a:ln>
-                <a:solidFill>
-                  <a:schemeClr val="tx1"/>
-                </a:solidFill>
-                <a:effectLst/>
-                <a:latin typeface="Arial" panose="020B0604020202020204" pitchFamily="34" charset="0"/>
-              </a:rPr>
-              <a:t>.</a:t>
-            </a:r>
-          </a:p>
-        </p:txBody>
-      </p:sp>
-    </p:spTree>
-    <p:extLst>
-      <p:ext uri="{BB962C8B-B14F-4D97-AF65-F5344CB8AC3E}">
-        <p14:creationId xmlns:p14="http://schemas.microsoft.com/office/powerpoint/2010/main" val="4233252692"/>
-      </p:ext>
-    </p:extLst>
-  </p:cSld>
-  <p:clrMapOvr>
-    <a:masterClrMapping/>
-  </p:clrMapOvr>
-</p:sld>
-</file>
-
-<file path=ppt/slides/slide3.xml><?xml version="1.0" encoding="utf-8"?>
 <p:sld xmlns:a="http://schemas.openxmlformats.org/drawingml/2006/main" xmlns:r="http://schemas.openxmlformats.org/officeDocument/2006/relationships" xmlns:p="http://schemas.openxmlformats.org/presentationml/2006/main">
   <p:cSld>
     <p:spTree>
@@ -3560,6 +3521,92 @@
     <p:extLst>
       <p:ext uri="{BB962C8B-B14F-4D97-AF65-F5344CB8AC3E}">
         <p14:creationId xmlns:p14="http://schemas.microsoft.com/office/powerpoint/2010/main" val="3095838342"/>
+      </p:ext>
+    </p:extLst>
+  </p:cSld>
+  <p:clrMapOvr>
+    <a:masterClrMapping/>
+  </p:clrMapOvr>
+</p:sld>
+</file>
+
+<file path=ppt/slides/slide3.xml><?xml version="1.0" encoding="utf-8"?>
+<p:sld xmlns:a="http://schemas.openxmlformats.org/drawingml/2006/main" xmlns:r="http://schemas.openxmlformats.org/officeDocument/2006/relationships" xmlns:p="http://schemas.openxmlformats.org/presentationml/2006/main">
+  <p:cSld>
+    <p:spTree>
+      <p:nvGrpSpPr>
+        <p:cNvPr id="1" name="">
+          <a:extLst>
+            <a:ext uri="{FF2B5EF4-FFF2-40B4-BE49-F238E27FC236}">
+              <a16:creationId xmlns:a16="http://schemas.microsoft.com/office/drawing/2014/main" id="{28B0B9D8-0E45-FA68-F76F-3C61845AC369}"/>
+            </a:ext>
+          </a:extLst>
+        </p:cNvPr>
+        <p:cNvGrpSpPr/>
+        <p:nvPr/>
+      </p:nvGrpSpPr>
+      <p:grpSpPr>
+        <a:xfrm>
+          <a:off x="0" y="0"/>
+          <a:ext cx="0" cy="0"/>
+          <a:chOff x="0" y="0"/>
+          <a:chExt cx="0" cy="0"/>
+        </a:xfrm>
+      </p:grpSpPr>
+      <p:sp>
+        <p:nvSpPr>
+          <p:cNvPr id="3" name="TextBox 2">
+            <a:extLst>
+              <a:ext uri="{FF2B5EF4-FFF2-40B4-BE49-F238E27FC236}">
+                <a16:creationId xmlns:a16="http://schemas.microsoft.com/office/drawing/2014/main" id="{4E760074-CF6F-B9E8-6689-401A03CEEFFD}"/>
+              </a:ext>
+            </a:extLst>
+          </p:cNvPr>
+          <p:cNvSpPr txBox="1"/>
+          <p:nvPr/>
+        </p:nvSpPr>
+        <p:spPr>
+          <a:xfrm>
+            <a:off x="217714" y="255046"/>
+            <a:ext cx="11756571" cy="355354"/>
+          </a:xfrm>
+          <a:prstGeom prst="rect">
+            <a:avLst/>
+          </a:prstGeom>
+          <a:noFill/>
+        </p:spPr>
+        <p:txBody>
+          <a:bodyPr wrap="square">
+            <a:spAutoFit/>
+          </a:bodyPr>
+          <a:lstStyle/>
+          <a:p>
+            <a:pPr>
+              <a:lnSpc>
+                <a:spcPct val="150000"/>
+              </a:lnSpc>
+              <a:buNone/>
+            </a:pPr>
+            <a:r>
+              <a:rPr kumimoji="0" lang="en-US" altLang="en-US" sz="1300" b="0" i="0" u="none" strike="noStrike" cap="none" normalizeH="0" baseline="0">
+                <a:ln>
+                  <a:noFill/>
+                </a:ln>
+                <a:solidFill>
+                  <a:schemeClr val="tx1"/>
+                </a:solidFill>
+                <a:effectLst/>
+                <a:latin typeface="Arial" panose="020B0604020202020204" pitchFamily="34" charset="0"/>
+              </a:rPr>
+              <a:t>.</a:t>
+            </a:r>
+          </a:p>
+        </p:txBody>
+      </p:sp>
+    </p:spTree>
+    <p:extLst>
+      <p:ext uri="{BB962C8B-B14F-4D97-AF65-F5344CB8AC3E}">
+        <p14:creationId xmlns:p14="http://schemas.microsoft.com/office/powerpoint/2010/main" val="526469105"/>
       </p:ext>
     </p:extLst>
   </p:cSld>

</xml_diff>